<commit_message>
data-eng decks 5-5 (w5d5s0 신설 · s1~s4 실측 반영) + bundles
Co-Authored-By: Claude Opus 5.5 <noreply@anthropic.com>
</commit_message>
<xml_diff>
--- a/data-eng/decks/w5d5s1.pptx
+++ b/data-eng/decks/w5d5s1.pptx
@@ -3100,7 +3100,7 @@
       <p:grpSpPr/>
       <p:sp>
         <p:nvSpPr>
-          <p:cNvPr id="2" name="Oval 1"/>
+          <p:cNvPr id="2" name="deckgen:decor"/>
           <p:cNvSpPr/>
           <p:nvPr/>
         </p:nvSpPr>
@@ -3130,7 +3130,7 @@
       </p:sp>
       <p:sp>
         <p:nvSpPr>
-          <p:cNvPr id="3" name="Oval 2"/>
+          <p:cNvPr id="3" name="deckgen:decor"/>
           <p:cNvSpPr/>
           <p:nvPr/>
         </p:nvSpPr>
@@ -3160,7 +3160,7 @@
       </p:sp>
       <p:sp>
         <p:nvSpPr>
-          <p:cNvPr id="4" name="Oval 3"/>
+          <p:cNvPr id="4" name="deckgen:decor"/>
           <p:cNvSpPr/>
           <p:nvPr/>
         </p:nvSpPr>
@@ -3190,7 +3190,7 @@
       </p:sp>
       <p:sp>
         <p:nvSpPr>
-          <p:cNvPr id="5" name="Rectangle 4"/>
+          <p:cNvPr id="5" name="deckgen:decor"/>
           <p:cNvSpPr/>
           <p:nvPr/>
         </p:nvSpPr>
@@ -3220,7 +3220,7 @@
       </p:sp>
       <p:sp>
         <p:nvSpPr>
-          <p:cNvPr id="6" name="Oval 5"/>
+          <p:cNvPr id="6" name="deckgen:decor"/>
           <p:cNvSpPr/>
           <p:nvPr/>
         </p:nvSpPr>
@@ -3250,7 +3250,7 @@
       </p:sp>
       <p:sp>
         <p:nvSpPr>
-          <p:cNvPr id="7" name="Oval 6"/>
+          <p:cNvPr id="7" name="deckgen:decor"/>
           <p:cNvSpPr/>
           <p:nvPr/>
         </p:nvSpPr>
@@ -3280,7 +3280,7 @@
       </p:sp>
       <p:sp>
         <p:nvSpPr>
-          <p:cNvPr id="8" name="Oval 7"/>
+          <p:cNvPr id="8" name="deckgen:decor"/>
           <p:cNvSpPr/>
           <p:nvPr/>
         </p:nvSpPr>
@@ -3310,7 +3310,7 @@
       </p:sp>
       <p:sp>
         <p:nvSpPr>
-          <p:cNvPr id="9" name="Oval 8"/>
+          <p:cNvPr id="9" name="deckgen:decor"/>
           <p:cNvSpPr/>
           <p:nvPr/>
         </p:nvSpPr>
@@ -3340,7 +3340,7 @@
       </p:sp>
       <p:sp>
         <p:nvSpPr>
-          <p:cNvPr id="10" name="Rectangle 9"/>
+          <p:cNvPr id="10" name="deckgen:decor"/>
           <p:cNvSpPr/>
           <p:nvPr/>
         </p:nvSpPr>
@@ -3600,7 +3600,7 @@
       <p:grpSpPr/>
       <p:sp>
         <p:nvSpPr>
-          <p:cNvPr id="2" name="Oval 1"/>
+          <p:cNvPr id="2" name="deckgen:decor"/>
           <p:cNvSpPr/>
           <p:nvPr/>
         </p:nvSpPr>
@@ -3630,7 +3630,7 @@
       </p:sp>
       <p:sp>
         <p:nvSpPr>
-          <p:cNvPr id="3" name="Oval 2"/>
+          <p:cNvPr id="3" name="deckgen:decor"/>
           <p:cNvSpPr/>
           <p:nvPr/>
         </p:nvSpPr>
@@ -3660,7 +3660,7 @@
       </p:sp>
       <p:sp>
         <p:nvSpPr>
-          <p:cNvPr id="4" name="Oval 3"/>
+          <p:cNvPr id="4" name="deckgen:decor"/>
           <p:cNvSpPr/>
           <p:nvPr/>
         </p:nvSpPr>
@@ -4808,7 +4808,7 @@
       <p:grpSpPr/>
       <p:sp>
         <p:nvSpPr>
-          <p:cNvPr id="2" name="Oval 1"/>
+          <p:cNvPr id="2" name="deckgen:decor"/>
           <p:cNvSpPr/>
           <p:nvPr/>
         </p:nvSpPr>
@@ -4838,7 +4838,7 @@
       </p:sp>
       <p:sp>
         <p:nvSpPr>
-          <p:cNvPr id="3" name="Oval 2"/>
+          <p:cNvPr id="3" name="deckgen:decor"/>
           <p:cNvSpPr/>
           <p:nvPr/>
         </p:nvSpPr>
@@ -5014,7 +5014,7 @@
                 <a:ea typeface="Pretendard"/>
                 <a:cs typeface="Pretendard"/>
               </a:rPr>
-              <a:t>파티션 수를 바꿔 가며 실행 시간과 Spark UI 의 셔플 지표를 직접 재고, 스큐를 일부러 만들어 봅니다</a:t>
+              <a:t>파티션 수를 바꿔 가며 분포와 Spark UI 의 셔플 지표를 직접 재고, 스큐를 일부러 만들어 봅니다</a:t>
             </a:r>
           </a:p>
         </p:txBody>
@@ -5246,7 +5246,7 @@
                 <a:ea typeface="Pretendard"/>
                 <a:cs typeface="Pretendard"/>
               </a:rPr>
-              <a:t>Stages 탭에서 Shuffle Read/Write 읽기</a:t>
+              <a:t>Jobs·Stages 탭에서 Shuffle Read/Write 읽기</a:t>
             </a:r>
           </a:p>
         </p:txBody>
@@ -5362,7 +5362,7 @@
                 <a:ea typeface="Pretendard"/>
                 <a:cs typeface="Pretendard"/>
               </a:rPr>
-              <a:t>shuffle.partitions 200·32·8 시간 비교</a:t>
+              <a:t>AQE 를 끄고 shuffle.partitions 200·8 비교</a:t>
             </a:r>
           </a:p>
         </p:txBody>
@@ -5478,7 +5478,7 @@
                 <a:ea typeface="Pretendard"/>
                 <a:cs typeface="Pretendard"/>
               </a:rPr>
-              <a:t>스큐를 만들어 한 태스크만 오래 걸리는 것 보기</a:t>
+              <a:t>스큐를 만들어 Task Max/Median 차이 보기</a:t>
             </a:r>
           </a:p>
         </p:txBody>
@@ -5590,7 +5590,7 @@
                 <a:ea typeface="Pretendard"/>
                 <a:cs typeface="Pretendard"/>
               </a:rPr>
-              <a:t>PySpark 셸(5-4 옵션) · UI 4040</a:t>
+              <a:t>실습점검으로 4040 열기 · bash lake-pyspark.sh</a:t>
             </a:r>
           </a:p>
         </p:txBody>
@@ -5615,7 +5615,7 @@
       <p:grpSpPr/>
       <p:sp>
         <p:nvSpPr>
-          <p:cNvPr id="2" name="Oval 1"/>
+          <p:cNvPr id="2" name="deckgen:decor"/>
           <p:cNvSpPr/>
           <p:nvPr/>
         </p:nvSpPr>
@@ -5645,7 +5645,7 @@
       </p:sp>
       <p:sp>
         <p:nvSpPr>
-          <p:cNvPr id="3" name="Oval 2"/>
+          <p:cNvPr id="3" name="deckgen:decor"/>
           <p:cNvSpPr/>
           <p:nvPr/>
         </p:nvSpPr>
@@ -5675,7 +5675,7 @@
       </p:sp>
       <p:sp>
         <p:nvSpPr>
-          <p:cNvPr id="4" name="Oval 3"/>
+          <p:cNvPr id="4" name="deckgen:decor"/>
           <p:cNvSpPr/>
           <p:nvPr/>
         </p:nvSpPr>
@@ -6606,7 +6606,7 @@
       <p:grpSpPr/>
       <p:sp>
         <p:nvSpPr>
-          <p:cNvPr id="2" name="Oval 1"/>
+          <p:cNvPr id="2" name="deckgen:decor"/>
           <p:cNvSpPr/>
           <p:nvPr/>
         </p:nvSpPr>
@@ -6636,7 +6636,7 @@
       </p:sp>
       <p:sp>
         <p:nvSpPr>
-          <p:cNvPr id="3" name="Oval 2"/>
+          <p:cNvPr id="3" name="deckgen:decor"/>
           <p:cNvSpPr/>
           <p:nvPr/>
         </p:nvSpPr>
@@ -6666,7 +6666,7 @@
       </p:sp>
       <p:sp>
         <p:nvSpPr>
-          <p:cNvPr id="4" name="Oval 3"/>
+          <p:cNvPr id="4" name="deckgen:decor"/>
           <p:cNvSpPr/>
           <p:nvPr/>
         </p:nvSpPr>
@@ -7782,7 +7782,7 @@
       <p:grpSpPr/>
       <p:sp>
         <p:nvSpPr>
-          <p:cNvPr id="2" name="Oval 1"/>
+          <p:cNvPr id="2" name="deckgen:decor"/>
           <p:cNvSpPr/>
           <p:nvPr/>
         </p:nvSpPr>
@@ -7812,7 +7812,7 @@
       </p:sp>
       <p:sp>
         <p:nvSpPr>
-          <p:cNvPr id="3" name="Oval 2"/>
+          <p:cNvPr id="3" name="deckgen:decor"/>
           <p:cNvSpPr/>
           <p:nvPr/>
         </p:nvSpPr>
@@ -7842,7 +7842,7 @@
       </p:sp>
       <p:sp>
         <p:nvSpPr>
-          <p:cNvPr id="4" name="Oval 3"/>
+          <p:cNvPr id="4" name="deckgen:decor"/>
           <p:cNvSpPr/>
           <p:nvPr/>
         </p:nvSpPr>
@@ -8538,7 +8538,7 @@
                 <a:ea typeface="Pretendard"/>
                 <a:cs typeface="Pretendard"/>
               </a:rPr>
-              <a:t>한 태스크만 오래 걸려 전체가 기다림 — 스큐</a:t>
+              <a:t>한 태스크만 오래 걸려 전체가 기다림 — UI 의 Task Max/Median 차이로 보임</a:t>
             </a:r>
           </a:p>
         </p:txBody>
@@ -8880,7 +8880,7 @@
       <p:grpSpPr/>
       <p:sp>
         <p:nvSpPr>
-          <p:cNvPr id="2" name="Oval 1"/>
+          <p:cNvPr id="2" name="deckgen:decor"/>
           <p:cNvSpPr/>
           <p:nvPr/>
         </p:nvSpPr>
@@ -8910,7 +8910,7 @@
       </p:sp>
       <p:sp>
         <p:nvSpPr>
-          <p:cNvPr id="3" name="Oval 2"/>
+          <p:cNvPr id="3" name="deckgen:decor"/>
           <p:cNvSpPr/>
           <p:nvPr/>
         </p:nvSpPr>
@@ -8940,7 +8940,7 @@
       </p:sp>
       <p:sp>
         <p:nvSpPr>
-          <p:cNvPr id="4" name="Oval 3"/>
+          <p:cNvPr id="4" name="deckgen:decor"/>
           <p:cNvSpPr/>
           <p:nvPr/>
         </p:nvSpPr>
@@ -9941,7 +9941,7 @@
       <p:grpSpPr/>
       <p:sp>
         <p:nvSpPr>
-          <p:cNvPr id="2" name="Oval 1"/>
+          <p:cNvPr id="2" name="deckgen:decor"/>
           <p:cNvSpPr/>
           <p:nvPr/>
         </p:nvSpPr>
@@ -9971,7 +9971,7 @@
       </p:sp>
       <p:sp>
         <p:nvSpPr>
-          <p:cNvPr id="3" name="Oval 2"/>
+          <p:cNvPr id="3" name="deckgen:decor"/>
           <p:cNvSpPr/>
           <p:nvPr/>
         </p:nvSpPr>
@@ -10001,7 +10001,7 @@
       </p:sp>
       <p:sp>
         <p:nvSpPr>
-          <p:cNvPr id="4" name="Oval 3"/>
+          <p:cNvPr id="4" name="deckgen:decor"/>
           <p:cNvSpPr/>
           <p:nvPr/>
         </p:nvSpPr>
@@ -10941,7 +10941,7 @@
       <p:grpSpPr/>
       <p:sp>
         <p:nvSpPr>
-          <p:cNvPr id="2" name="Oval 1"/>
+          <p:cNvPr id="2" name="deckgen:decor"/>
           <p:cNvSpPr/>
           <p:nvPr/>
         </p:nvSpPr>
@@ -10971,7 +10971,7 @@
       </p:sp>
       <p:sp>
         <p:nvSpPr>
-          <p:cNvPr id="3" name="Oval 2"/>
+          <p:cNvPr id="3" name="deckgen:decor"/>
           <p:cNvSpPr/>
           <p:nvPr/>
         </p:nvSpPr>
@@ -11001,7 +11001,7 @@
       </p:sp>
       <p:sp>
         <p:nvSpPr>
-          <p:cNvPr id="4" name="Oval 3"/>
+          <p:cNvPr id="4" name="deckgen:decor"/>
           <p:cNvSpPr/>
           <p:nvPr/>
         </p:nvSpPr>
@@ -12021,7 +12021,7 @@
       <p:grpSpPr/>
       <p:sp>
         <p:nvSpPr>
-          <p:cNvPr id="2" name="Oval 1"/>
+          <p:cNvPr id="2" name="deckgen:decor"/>
           <p:cNvSpPr/>
           <p:nvPr/>
         </p:nvSpPr>
@@ -12051,7 +12051,7 @@
       </p:sp>
       <p:sp>
         <p:nvSpPr>
-          <p:cNvPr id="3" name="Oval 2"/>
+          <p:cNvPr id="3" name="deckgen:decor"/>
           <p:cNvSpPr/>
           <p:nvPr/>
         </p:nvSpPr>
@@ -12081,7 +12081,7 @@
       </p:sp>
       <p:sp>
         <p:nvSpPr>
-          <p:cNvPr id="4" name="Oval 3"/>
+          <p:cNvPr id="4" name="deckgen:decor"/>
           <p:cNvSpPr/>
           <p:nvPr/>
         </p:nvSpPr>
@@ -13329,7 +13329,7 @@
                 <a:ea typeface="Pretendard"/>
                 <a:cs typeface="Pretendard"/>
               </a:rPr>
-              <a:t>치우칠 수 있음</a:t>
+              <a:t>원래 조각이 고르지 않으면 치우침</a:t>
             </a:r>
           </a:p>
         </p:txBody>
@@ -13732,7 +13732,7 @@
       <p:grpSpPr/>
       <p:sp>
         <p:nvSpPr>
-          <p:cNvPr id="2" name="Oval 1"/>
+          <p:cNvPr id="2" name="deckgen:decor"/>
           <p:cNvSpPr/>
           <p:nvPr/>
         </p:nvSpPr>
@@ -13762,7 +13762,7 @@
       </p:sp>
       <p:sp>
         <p:nvSpPr>
-          <p:cNvPr id="3" name="Oval 2"/>
+          <p:cNvPr id="3" name="deckgen:decor"/>
           <p:cNvSpPr/>
           <p:nvPr/>
         </p:nvSpPr>
@@ -13792,7 +13792,7 @@
       </p:sp>
       <p:sp>
         <p:nvSpPr>
-          <p:cNvPr id="4" name="Oval 3"/>
+          <p:cNvPr id="4" name="deckgen:decor"/>
           <p:cNvSpPr/>
           <p:nvPr/>
         </p:nvSpPr>
@@ -15531,7 +15531,7 @@
                 <a:ea typeface="Pretendard"/>
                 <a:cs typeface="Pretendard"/>
               </a:rPr>
-              <a:t>Spark 3 부터 AQE 가 기본 — 실행 중 실제 크기를 보고 셔플 파티션을 줄여 준다. 그래도 원리를 알아야 UI 를 읽는다</a:t>
+              <a:t>Spark 3 부터 AQE 가 기본 — 실행 중 셔플 파티션을 알아서 합쳐 주므로 shuffle.partitions 를 바꿔도 차이가 작다. 그래도 원리를 알아야 UI 를 읽는다</a:t>
             </a:r>
           </a:p>
         </p:txBody>

</xml_diff>